<commit_message>
Update PPTX theme to lavender-purple
</commit_message>
<xml_diff>
--- a/Joe_Wei_成绩总览.pptx
+++ b/Joe_Wei_成绩总览.pptx
@@ -132,7 +132,7 @@
           </c:tx>
           <c:spPr>
             <a:solidFill>
-              <a:srgbClr val="3D8B8B"/>
+              <a:srgbClr val="6B5B95"/>
             </a:solidFill>
           </c:spPr>
           <c:cat>
@@ -229,7 +229,7 @@
           </c:tx>
           <c:spPr>
             <a:solidFill>
-              <a:srgbClr val="4A90D9"/>
+              <a:srgbClr val="8B6EB8"/>
             </a:solidFill>
           </c:spPr>
           <c:cat>
@@ -326,7 +326,7 @@
           </c:tx>
           <c:spPr>
             <a:solidFill>
-              <a:srgbClr val="5EF5C0"/>
+              <a:srgbClr val="C49EF0"/>
             </a:solidFill>
           </c:spPr>
           <c:cat>
@@ -424,7 +424,7 @@
         <c:spPr>
           <a:ln>
             <a:solidFill>
-              <a:srgbClr val="1C2533"/>
+              <a:srgbClr val="2A2F3E"/>
             </a:solidFill>
           </a:ln>
         </c:spPr>
@@ -435,7 +435,7 @@
             <a:pPr>
               <a:defRPr sz="1000">
                 <a:solidFill>
-                  <a:srgbClr val="E6EDF3"/>
+                  <a:srgbClr val="B8A9C9"/>
                 </a:solidFill>
                 <a:latin typeface="Calibri"/>
               </a:defRPr>
@@ -461,7 +461,7 @@
           <c:spPr>
             <a:ln>
               <a:solidFill>
-                <a:srgbClr val="1C2533"/>
+                <a:srgbClr val="2A2F3E"/>
               </a:solidFill>
             </a:ln>
           </c:spPr>
@@ -472,7 +472,7 @@
         <c:spPr>
           <a:ln>
             <a:solidFill>
-              <a:srgbClr val="1C2533"/>
+              <a:srgbClr val="2A2F3E"/>
             </a:solidFill>
           </a:ln>
         </c:spPr>
@@ -483,7 +483,7 @@
             <a:pPr>
               <a:defRPr sz="1000">
                 <a:solidFill>
-                  <a:srgbClr val="8B95A5"/>
+                  <a:srgbClr val="7A728E"/>
                 </a:solidFill>
                 <a:latin typeface="Calibri"/>
               </a:defRPr>
@@ -505,7 +505,7 @@
           <a:pPr>
             <a:defRPr sz="1100">
               <a:solidFill>
-                <a:srgbClr val="E6EDF3"/>
+                <a:srgbClr val="B8A9C9"/>
               </a:solidFill>
             </a:defRPr>
           </a:pPr>
@@ -3507,7 +3507,7 @@
     <p:bg>
       <p:bgPr>
         <a:solidFill>
-          <a:srgbClr val="0A0E17"/>
+          <a:srgbClr val="1A1F2E"/>
         </a:solidFill>
         <a:effectLst/>
       </p:bgPr>
@@ -3544,7 +3544,7 @@
             <a:pPr>
               <a:defRPr sz="3000" b="1">
                 <a:solidFill>
-                  <a:srgbClr val="E6EDF3"/>
+                  <a:srgbClr val="B8A9C9"/>
                 </a:solidFill>
                 <a:latin typeface="Calibri"/>
               </a:defRPr>
@@ -3580,7 +3580,7 @@
             <a:r>
               <a:rPr sz="1300" b="0">
                 <a:solidFill>
-                  <a:srgbClr val="8B95A5"/>
+                  <a:srgbClr val="7A728E"/>
                 </a:solidFill>
                 <a:latin typeface="Calibri"/>
               </a:rPr>
@@ -3589,7 +3589,7 @@
             <a:r>
               <a:rPr sz="1300" b="0">
                 <a:solidFill>
-                  <a:srgbClr val="E6EDF3"/>
+                  <a:srgbClr val="E8E0F0"/>
                 </a:solidFill>
                 <a:latin typeface="Calibri"/>
               </a:rPr>
@@ -3598,7 +3598,7 @@
             <a:r>
               <a:rPr sz="1300" b="1">
                 <a:solidFill>
-                  <a:srgbClr val="5EF5C0"/>
+                  <a:srgbClr val="C49EF0"/>
                 </a:solidFill>
                 <a:latin typeface="Calibri"/>
               </a:rPr>
@@ -3632,7 +3632,7 @@
             <a:r>
               <a:rPr sz="1400" b="1">
                 <a:solidFill>
-                  <a:srgbClr val="5EF5C0"/>
+                  <a:srgbClr val="C49EF0"/>
                 </a:solidFill>
                 <a:latin typeface="Calibri"/>
               </a:rPr>
@@ -3641,7 +3641,7 @@
             <a:r>
               <a:rPr sz="1400" b="1">
                 <a:solidFill>
-                  <a:srgbClr val="FFA860"/>
+                  <a:srgbClr val="E8B88A"/>
                 </a:solidFill>
                 <a:latin typeface="Calibri"/>
               </a:rPr>
@@ -3670,7 +3670,84 @@
       </p:graphicFrame>
       <p:sp>
         <p:nvSpPr>
-          <p:cNvPr id="6" name="TextBox 5"/>
+          <p:cNvPr id="6" name="Rectangle 5"/>
+          <p:cNvSpPr/>
+          <p:nvPr/>
+        </p:nvSpPr>
+        <p:spPr>
+          <a:xfrm>
+            <a:off x="365760" y="3090672"/>
+            <a:ext cx="11430000" cy="25400"/>
+          </a:xfrm>
+          <a:prstGeom prst="rect">
+            <a:avLst/>
+          </a:prstGeom>
+          <a:solidFill>
+            <a:srgbClr val="C49EF0"/>
+          </a:solidFill>
+          <a:ln>
+            <a:noFill/>
+          </a:ln>
+        </p:spPr>
+        <p:style>
+          <a:lnRef idx="1">
+            <a:schemeClr val="accent1"/>
+          </a:lnRef>
+          <a:fillRef idx="3">
+            <a:schemeClr val="accent1"/>
+          </a:fillRef>
+          <a:effectRef idx="2">
+            <a:schemeClr val="accent1"/>
+          </a:effectRef>
+          <a:fontRef idx="minor">
+            <a:schemeClr val="lt1"/>
+          </a:fontRef>
+        </p:style>
+        <p:txBody>
+          <a:bodyPr rtlCol="0" anchor="ctr"/>
+          <a:lstStyle/>
+          <a:p>
+            <a:pPr algn="ctr"/>
+          </a:p>
+        </p:txBody>
+      </p:sp>
+      <p:sp>
+        <p:nvSpPr>
+          <p:cNvPr id="7" name="TextBox 6"/>
+          <p:cNvSpPr txBox="1"/>
+          <p:nvPr/>
+        </p:nvSpPr>
+        <p:spPr>
+          <a:xfrm>
+            <a:off x="11155680" y="2862072"/>
+            <a:ext cx="731520" cy="228600"/>
+          </a:xfrm>
+          <a:prstGeom prst="rect">
+            <a:avLst/>
+          </a:prstGeom>
+          <a:noFill/>
+        </p:spPr>
+        <p:txBody>
+          <a:bodyPr wrap="none">
+            <a:spAutoFit/>
+          </a:bodyPr>
+          <a:lstStyle/>
+          <a:p>
+            <a:r>
+              <a:rPr sz="900" b="1">
+                <a:solidFill>
+                  <a:srgbClr val="C49EF0"/>
+                </a:solidFill>
+                <a:latin typeface="Calibri"/>
+              </a:rPr>
+              <a:t>A线 90</a:t>
+            </a:r>
+          </a:p>
+        </p:txBody>
+      </p:sp>
+      <p:sp>
+        <p:nvSpPr>
+          <p:cNvPr id="8" name="TextBox 7"/>
           <p:cNvSpPr txBox="1"/>
           <p:nvPr/>
         </p:nvSpPr>
@@ -3693,7 +3770,7 @@
             <a:r>
               <a:rPr sz="1300">
                 <a:solidFill>
-                  <a:srgbClr val="5EF5C0"/>
+                  <a:srgbClr val="9EDBB8"/>
                 </a:solidFill>
                 <a:latin typeface="Calibri"/>
               </a:rPr>
@@ -3704,7 +3781,7 @@
       </p:sp>
       <p:sp>
         <p:nvSpPr>
-          <p:cNvPr id="7" name="TextBox 6"/>
+          <p:cNvPr id="9" name="TextBox 8"/>
           <p:cNvSpPr txBox="1"/>
           <p:nvPr/>
         </p:nvSpPr>
@@ -3727,7 +3804,7 @@
             <a:r>
               <a:rPr sz="1300">
                 <a:solidFill>
-                  <a:srgbClr val="6EE7FF"/>
+                  <a:srgbClr val="A786C8"/>
                 </a:solidFill>
                 <a:latin typeface="Calibri"/>
               </a:rPr>
@@ -3738,7 +3815,7 @@
       </p:sp>
       <p:sp>
         <p:nvSpPr>
-          <p:cNvPr id="8" name="TextBox 7"/>
+          <p:cNvPr id="10" name="TextBox 9"/>
           <p:cNvSpPr txBox="1"/>
           <p:nvPr/>
         </p:nvSpPr>
@@ -3761,7 +3838,7 @@
             <a:r>
               <a:rPr sz="1300">
                 <a:solidFill>
-                  <a:srgbClr val="FF7A85"/>
+                  <a:srgbClr val="D47A8A"/>
                 </a:solidFill>
                 <a:latin typeface="Calibri"/>
               </a:rPr>

</xml_diff>